<commit_message>
recent updates and ready for final training
</commit_message>
<xml_diff>
--- a/outputs/presentation/Project_Review_Presentation_v2.pptx
+++ b/outputs/presentation/Project_Review_Presentation_v2.pptx
@@ -310,7 +310,7 @@
           <a:p>
             <a:fld id="{5BCAD085-E8A6-8845-BD4E-CB4CCA059FC4}" type="datetimeFigureOut">
               <a:rPr lang="en-US" smtClean="0"/>
-              <a:t>7/29/2026</a:t>
+              <a:t>9/8/2026</a:t>
             </a:fld>
             <a:endParaRPr lang="en-US"/>
           </a:p>
@@ -478,7 +478,7 @@
           <a:p>
             <a:fld id="{5BCAD085-E8A6-8845-BD4E-CB4CCA059FC4}" type="datetimeFigureOut">
               <a:rPr lang="en-US" smtClean="0"/>
-              <a:t>7/29/2026</a:t>
+              <a:t>9/8/2026</a:t>
             </a:fld>
             <a:endParaRPr lang="en-US"/>
           </a:p>
@@ -656,7 +656,7 @@
           <a:p>
             <a:fld id="{5BCAD085-E8A6-8845-BD4E-CB4CCA059FC4}" type="datetimeFigureOut">
               <a:rPr lang="en-US" smtClean="0"/>
-              <a:t>7/29/2026</a:t>
+              <a:t>9/8/2026</a:t>
             </a:fld>
             <a:endParaRPr lang="en-US"/>
           </a:p>
@@ -824,7 +824,7 @@
           <a:p>
             <a:fld id="{5BCAD085-E8A6-8845-BD4E-CB4CCA059FC4}" type="datetimeFigureOut">
               <a:rPr lang="en-US" smtClean="0"/>
-              <a:t>7/29/2026</a:t>
+              <a:t>9/8/2026</a:t>
             </a:fld>
             <a:endParaRPr lang="en-US"/>
           </a:p>
@@ -1069,7 +1069,7 @@
           <a:p>
             <a:fld id="{5BCAD085-E8A6-8845-BD4E-CB4CCA059FC4}" type="datetimeFigureOut">
               <a:rPr lang="en-US" smtClean="0"/>
-              <a:t>7/29/2026</a:t>
+              <a:t>9/8/2026</a:t>
             </a:fld>
             <a:endParaRPr lang="en-US"/>
           </a:p>
@@ -1354,7 +1354,7 @@
           <a:p>
             <a:fld id="{5BCAD085-E8A6-8845-BD4E-CB4CCA059FC4}" type="datetimeFigureOut">
               <a:rPr lang="en-US" smtClean="0"/>
-              <a:t>7/29/2026</a:t>
+              <a:t>9/8/2026</a:t>
             </a:fld>
             <a:endParaRPr lang="en-US"/>
           </a:p>
@@ -1773,7 +1773,7 @@
           <a:p>
             <a:fld id="{5BCAD085-E8A6-8845-BD4E-CB4CCA059FC4}" type="datetimeFigureOut">
               <a:rPr lang="en-US" smtClean="0"/>
-              <a:t>7/29/2026</a:t>
+              <a:t>9/8/2026</a:t>
             </a:fld>
             <a:endParaRPr lang="en-US"/>
           </a:p>
@@ -1890,7 +1890,7 @@
           <a:p>
             <a:fld id="{5BCAD085-E8A6-8845-BD4E-CB4CCA059FC4}" type="datetimeFigureOut">
               <a:rPr lang="en-US" smtClean="0"/>
-              <a:t>7/29/2026</a:t>
+              <a:t>9/8/2026</a:t>
             </a:fld>
             <a:endParaRPr lang="en-US"/>
           </a:p>
@@ -1985,7 +1985,7 @@
           <a:p>
             <a:fld id="{5BCAD085-E8A6-8845-BD4E-CB4CCA059FC4}" type="datetimeFigureOut">
               <a:rPr lang="en-US" smtClean="0"/>
-              <a:t>7/29/2026</a:t>
+              <a:t>9/8/2026</a:t>
             </a:fld>
             <a:endParaRPr lang="en-US"/>
           </a:p>
@@ -2260,7 +2260,7 @@
           <a:p>
             <a:fld id="{5BCAD085-E8A6-8845-BD4E-CB4CCA059FC4}" type="datetimeFigureOut">
               <a:rPr lang="en-US" smtClean="0"/>
-              <a:t>7/29/2026</a:t>
+              <a:t>9/8/2026</a:t>
             </a:fld>
             <a:endParaRPr lang="en-US"/>
           </a:p>
@@ -2512,7 +2512,7 @@
           <a:p>
             <a:fld id="{5BCAD085-E8A6-8845-BD4E-CB4CCA059FC4}" type="datetimeFigureOut">
               <a:rPr lang="en-US" smtClean="0"/>
-              <a:t>7/29/2026</a:t>
+              <a:t>9/8/2026</a:t>
             </a:fld>
             <a:endParaRPr lang="en-US"/>
           </a:p>
@@ -2723,7 +2723,7 @@
           <a:p>
             <a:fld id="{5BCAD085-E8A6-8845-BD4E-CB4CCA059FC4}" type="datetimeFigureOut">
               <a:rPr lang="en-US" smtClean="0"/>
-              <a:t>7/29/2026</a:t>
+              <a:t>9/8/2026</a:t>
             </a:fld>
             <a:endParaRPr lang="en-US"/>
           </a:p>
@@ -3874,7 +3874,7 @@
         </p:nvSpPr>
         <p:spPr>
           <a:xfrm>
-            <a:off x="457200" y="731520"/>
+            <a:off x="603739" y="731520"/>
             <a:ext cx="8229600" cy="731520"/>
           </a:xfrm>
           <a:prstGeom prst="rect">
@@ -4325,6 +4325,7 @@
               </a:defRPr>
             </a:pPr>
             <a:r>
+              <a:rPr dirty="0"/>
               <a:t>Research Gap</a:t>
             </a:r>
           </a:p>
@@ -4618,26 +4619,55 @@
               <a:defRPr sz="1800"/>
             </a:pPr>
             <a:r>
+              <a:rPr dirty="0"/>
               <a:t>1. To design a Phenotype-Guided Asymmetric Attention mechanism where clinical features selectively query MRI, PET, and genetics.</a:t>
             </a:r>
-            <a:br/>
-            <a:br/>
-            <a:r>
+            <a:br>
+              <a:rPr dirty="0"/>
+            </a:br>
+            <a:br>
+              <a:rPr dirty="0"/>
+            </a:br>
+            <a:r>
+              <a:rPr dirty="0"/>
               <a:t>2. To implement a Shared-Private Latent Decomposition using HSIC orthogonality to disentangle disease biomarkers from noise.</a:t>
             </a:r>
-            <a:br/>
-            <a:br/>
-            <a:r>
-              <a:t>3. To build a federated learning pipeline (FedAvg) that trains across multiple clinical sites without centralizing raw data.</a:t>
-            </a:r>
-            <a:br/>
-            <a:br/>
-            <a:r>
+            <a:br>
+              <a:rPr dirty="0"/>
+            </a:br>
+            <a:br>
+              <a:rPr dirty="0"/>
+            </a:br>
+            <a:r>
+              <a:rPr dirty="0"/>
+              <a:t>3. To build a federated learning pipeline (</a:t>
+            </a:r>
+            <a:r>
+              <a:rPr dirty="0" err="1"/>
+              <a:t>FedAvg</a:t>
+            </a:r>
+            <a:r>
+              <a:rPr dirty="0"/>
+              <a:t>) that trains across multiple clinical sites without centralizing raw data.</a:t>
+            </a:r>
+            <a:br>
+              <a:rPr dirty="0"/>
+            </a:br>
+            <a:br>
+              <a:rPr dirty="0"/>
+            </a:br>
+            <a:r>
+              <a:rPr dirty="0"/>
               <a:t>4. To incorporate robustness features (learned mask tokens for missing modalities, Monte Carlo Dropout for uncertainty).</a:t>
             </a:r>
-            <a:br/>
-            <a:br/>
-            <a:r>
+            <a:br>
+              <a:rPr dirty="0"/>
+            </a:br>
+            <a:br>
+              <a:rPr dirty="0"/>
+            </a:br>
+            <a:r>
+              <a:rPr dirty="0"/>
               <a:t>5. To provide a multi-level explainability suite (Attention Maps, Integrated Gradients, Counterfactuals).</a:t>
             </a:r>
           </a:p>

</xml_diff>